<commit_message>
new cover and flyer
</commit_message>
<xml_diff>
--- a/flyer/MSE-Project-Flyer-A5.pptx
+++ b/flyer/MSE-Project-Flyer-A5.pptx
@@ -129,7 +129,7 @@
           <p:cNvPr id="2" name="Title 1">
             <a:extLst>
               <a:ext uri="{FF2B5EF4-FFF2-40B4-BE49-F238E27FC236}">
-                <a16:creationId xmlns:a16="http://schemas.microsoft.com/office/drawing/2014/main" id="{95017EA2-7241-4930-B605-7F4DD3A0C460}"/>
+                <a16:creationId xmlns:a16="http://schemas.microsoft.com/office/drawing/2014/main" id="{C84612D4-3EE0-87E6-35C4-E62053A6CFFA}"/>
               </a:ext>
             </a:extLst>
           </p:cNvPr>
@@ -166,7 +166,7 @@
           <p:cNvPr id="3" name="Subtitle 2">
             <a:extLst>
               <a:ext uri="{FF2B5EF4-FFF2-40B4-BE49-F238E27FC236}">
-                <a16:creationId xmlns:a16="http://schemas.microsoft.com/office/drawing/2014/main" id="{AC7E2B3A-9947-771E-A0BF-BF23F6E5CC55}"/>
+                <a16:creationId xmlns:a16="http://schemas.microsoft.com/office/drawing/2014/main" id="{59BD263F-58D8-B611-E55E-09EABA62A1EE}"/>
               </a:ext>
             </a:extLst>
           </p:cNvPr>
@@ -236,7 +236,7 @@
           <p:cNvPr id="4" name="Date Placeholder 3">
             <a:extLst>
               <a:ext uri="{FF2B5EF4-FFF2-40B4-BE49-F238E27FC236}">
-                <a16:creationId xmlns:a16="http://schemas.microsoft.com/office/drawing/2014/main" id="{8B98F8F8-8461-57F3-52FD-596BB515C79D}"/>
+                <a16:creationId xmlns:a16="http://schemas.microsoft.com/office/drawing/2014/main" id="{D39988AF-0EE4-4FB7-8308-F05B6749C06B}"/>
               </a:ext>
             </a:extLst>
           </p:cNvPr>
@@ -252,9 +252,9 @@
           <a:bodyPr/>
           <a:lstStyle/>
           <a:p>
-            <a:fld id="{B6498013-008A-4316-B9B6-B44ADD31C3FE}" type="datetimeFigureOut">
+            <a:fld id="{B85B0049-ECB1-450D-8AAD-F92528287912}" type="datetimeFigureOut">
               <a:rPr lang="en-US" smtClean="0"/>
-              <a:t>10/28/2026</a:t>
+              <a:t>10/29/2026</a:t>
             </a:fld>
             <a:endParaRPr lang="en-US"/>
           </a:p>
@@ -265,7 +265,7 @@
           <p:cNvPr id="5" name="Footer Placeholder 4">
             <a:extLst>
               <a:ext uri="{FF2B5EF4-FFF2-40B4-BE49-F238E27FC236}">
-                <a16:creationId xmlns:a16="http://schemas.microsoft.com/office/drawing/2014/main" id="{4AD9076E-2314-85B6-23CB-5493642CC42E}"/>
+                <a16:creationId xmlns:a16="http://schemas.microsoft.com/office/drawing/2014/main" id="{96EA3774-DFF6-9D63-28D6-93AA1C211505}"/>
               </a:ext>
             </a:extLst>
           </p:cNvPr>
@@ -290,7 +290,7 @@
           <p:cNvPr id="6" name="Slide Number Placeholder 5">
             <a:extLst>
               <a:ext uri="{FF2B5EF4-FFF2-40B4-BE49-F238E27FC236}">
-                <a16:creationId xmlns:a16="http://schemas.microsoft.com/office/drawing/2014/main" id="{2256FF20-7901-8043-99F1-F5EFAB5D9593}"/>
+                <a16:creationId xmlns:a16="http://schemas.microsoft.com/office/drawing/2014/main" id="{38ADC12B-EDDB-D8DD-8635-CEE76DA691C1}"/>
               </a:ext>
             </a:extLst>
           </p:cNvPr>
@@ -306,7 +306,7 @@
           <a:bodyPr/>
           <a:lstStyle/>
           <a:p>
-            <a:fld id="{BED681DC-90D6-4908-8B41-16ED1ABBC1BC}" type="slidenum">
+            <a:fld id="{91787D38-685D-49A4-927F-FD1C1A5E76DF}" type="slidenum">
               <a:rPr lang="en-US" smtClean="0"/>
               <a:t>‹#›</a:t>
             </a:fld>
@@ -317,7 +317,7 @@
     </p:spTree>
     <p:extLst>
       <p:ext uri="{BB962C8B-B14F-4D97-AF65-F5344CB8AC3E}">
-        <p14:creationId xmlns:p14="http://schemas.microsoft.com/office/powerpoint/2010/main" val="2624444455"/>
+        <p14:creationId xmlns:p14="http://schemas.microsoft.com/office/powerpoint/2010/main" val="1518922744"/>
       </p:ext>
     </p:extLst>
   </p:cSld>
@@ -349,7 +349,7 @@
           <p:cNvPr id="2" name="Title 1">
             <a:extLst>
               <a:ext uri="{FF2B5EF4-FFF2-40B4-BE49-F238E27FC236}">
-                <a16:creationId xmlns:a16="http://schemas.microsoft.com/office/drawing/2014/main" id="{04A7779C-004E-E0D8-65DB-04AECD8AE269}"/>
+                <a16:creationId xmlns:a16="http://schemas.microsoft.com/office/drawing/2014/main" id="{F4648A7C-C2B3-4FA5-2F9E-C6A57C5350B0}"/>
               </a:ext>
             </a:extLst>
           </p:cNvPr>
@@ -377,7 +377,7 @@
           <p:cNvPr id="3" name="Vertical Text Placeholder 2">
             <a:extLst>
               <a:ext uri="{FF2B5EF4-FFF2-40B4-BE49-F238E27FC236}">
-                <a16:creationId xmlns:a16="http://schemas.microsoft.com/office/drawing/2014/main" id="{F8416706-5629-0754-3638-44AAE46B0D69}"/>
+                <a16:creationId xmlns:a16="http://schemas.microsoft.com/office/drawing/2014/main" id="{E11E96F4-66DE-0F82-EAC6-85C8C0B4F932}"/>
               </a:ext>
             </a:extLst>
           </p:cNvPr>
@@ -434,7 +434,7 @@
           <p:cNvPr id="4" name="Date Placeholder 3">
             <a:extLst>
               <a:ext uri="{FF2B5EF4-FFF2-40B4-BE49-F238E27FC236}">
-                <a16:creationId xmlns:a16="http://schemas.microsoft.com/office/drawing/2014/main" id="{D0CDCA0F-DE4F-0E93-20C1-90B6C1ADA643}"/>
+                <a16:creationId xmlns:a16="http://schemas.microsoft.com/office/drawing/2014/main" id="{5F0A8E32-430E-B147-9B41-166975F959E0}"/>
               </a:ext>
             </a:extLst>
           </p:cNvPr>
@@ -450,9 +450,9 @@
           <a:bodyPr/>
           <a:lstStyle/>
           <a:p>
-            <a:fld id="{B6498013-008A-4316-B9B6-B44ADD31C3FE}" type="datetimeFigureOut">
+            <a:fld id="{B85B0049-ECB1-450D-8AAD-F92528287912}" type="datetimeFigureOut">
               <a:rPr lang="en-US" smtClean="0"/>
-              <a:t>10/28/2026</a:t>
+              <a:t>10/29/2026</a:t>
             </a:fld>
             <a:endParaRPr lang="en-US"/>
           </a:p>
@@ -463,7 +463,7 @@
           <p:cNvPr id="5" name="Footer Placeholder 4">
             <a:extLst>
               <a:ext uri="{FF2B5EF4-FFF2-40B4-BE49-F238E27FC236}">
-                <a16:creationId xmlns:a16="http://schemas.microsoft.com/office/drawing/2014/main" id="{3221C824-EF9B-8C95-00BB-896C08CDF5B9}"/>
+                <a16:creationId xmlns:a16="http://schemas.microsoft.com/office/drawing/2014/main" id="{33B92B24-4DD1-D6A6-A01B-3ABF2011A18C}"/>
               </a:ext>
             </a:extLst>
           </p:cNvPr>
@@ -488,7 +488,7 @@
           <p:cNvPr id="6" name="Slide Number Placeholder 5">
             <a:extLst>
               <a:ext uri="{FF2B5EF4-FFF2-40B4-BE49-F238E27FC236}">
-                <a16:creationId xmlns:a16="http://schemas.microsoft.com/office/drawing/2014/main" id="{6CB513D3-00FB-40F3-982F-67C778022DA6}"/>
+                <a16:creationId xmlns:a16="http://schemas.microsoft.com/office/drawing/2014/main" id="{9327C921-695D-0507-3D13-F23BCD4BE5BD}"/>
               </a:ext>
             </a:extLst>
           </p:cNvPr>
@@ -504,7 +504,7 @@
           <a:bodyPr/>
           <a:lstStyle/>
           <a:p>
-            <a:fld id="{BED681DC-90D6-4908-8B41-16ED1ABBC1BC}" type="slidenum">
+            <a:fld id="{91787D38-685D-49A4-927F-FD1C1A5E76DF}" type="slidenum">
               <a:rPr lang="en-US" smtClean="0"/>
               <a:t>‹#›</a:t>
             </a:fld>
@@ -515,7 +515,7 @@
     </p:spTree>
     <p:extLst>
       <p:ext uri="{BB962C8B-B14F-4D97-AF65-F5344CB8AC3E}">
-        <p14:creationId xmlns:p14="http://schemas.microsoft.com/office/powerpoint/2010/main" val="287294300"/>
+        <p14:creationId xmlns:p14="http://schemas.microsoft.com/office/powerpoint/2010/main" val="396129875"/>
       </p:ext>
     </p:extLst>
   </p:cSld>
@@ -547,7 +547,7 @@
           <p:cNvPr id="2" name="Vertical Title 1">
             <a:extLst>
               <a:ext uri="{FF2B5EF4-FFF2-40B4-BE49-F238E27FC236}">
-                <a16:creationId xmlns:a16="http://schemas.microsoft.com/office/drawing/2014/main" id="{97F09810-3613-9246-BB98-43074313FE44}"/>
+                <a16:creationId xmlns:a16="http://schemas.microsoft.com/office/drawing/2014/main" id="{5C94C177-2E96-CDA9-BF5C-DF33852939AF}"/>
               </a:ext>
             </a:extLst>
           </p:cNvPr>
@@ -580,7 +580,7 @@
           <p:cNvPr id="3" name="Vertical Text Placeholder 2">
             <a:extLst>
               <a:ext uri="{FF2B5EF4-FFF2-40B4-BE49-F238E27FC236}">
-                <a16:creationId xmlns:a16="http://schemas.microsoft.com/office/drawing/2014/main" id="{0A4B7D25-5B87-F9A1-45AE-F7780C199791}"/>
+                <a16:creationId xmlns:a16="http://schemas.microsoft.com/office/drawing/2014/main" id="{3D4088AA-BFE4-CD65-F889-45222DB2993D}"/>
               </a:ext>
             </a:extLst>
           </p:cNvPr>
@@ -642,7 +642,7 @@
           <p:cNvPr id="4" name="Date Placeholder 3">
             <a:extLst>
               <a:ext uri="{FF2B5EF4-FFF2-40B4-BE49-F238E27FC236}">
-                <a16:creationId xmlns:a16="http://schemas.microsoft.com/office/drawing/2014/main" id="{05E38829-9C2C-AFE5-25A7-6591D4BAE634}"/>
+                <a16:creationId xmlns:a16="http://schemas.microsoft.com/office/drawing/2014/main" id="{75798A18-AC7E-395F-65A7-ECC77BF1F7AE}"/>
               </a:ext>
             </a:extLst>
           </p:cNvPr>
@@ -658,9 +658,9 @@
           <a:bodyPr/>
           <a:lstStyle/>
           <a:p>
-            <a:fld id="{B6498013-008A-4316-B9B6-B44ADD31C3FE}" type="datetimeFigureOut">
+            <a:fld id="{B85B0049-ECB1-450D-8AAD-F92528287912}" type="datetimeFigureOut">
               <a:rPr lang="en-US" smtClean="0"/>
-              <a:t>10/28/2026</a:t>
+              <a:t>10/29/2026</a:t>
             </a:fld>
             <a:endParaRPr lang="en-US"/>
           </a:p>
@@ -671,7 +671,7 @@
           <p:cNvPr id="5" name="Footer Placeholder 4">
             <a:extLst>
               <a:ext uri="{FF2B5EF4-FFF2-40B4-BE49-F238E27FC236}">
-                <a16:creationId xmlns:a16="http://schemas.microsoft.com/office/drawing/2014/main" id="{6917E10E-8A53-647B-4F3D-65FCDDB26D14}"/>
+                <a16:creationId xmlns:a16="http://schemas.microsoft.com/office/drawing/2014/main" id="{0C65305C-21C4-E1C7-AA31-1CBCE1D237CA}"/>
               </a:ext>
             </a:extLst>
           </p:cNvPr>
@@ -696,7 +696,7 @@
           <p:cNvPr id="6" name="Slide Number Placeholder 5">
             <a:extLst>
               <a:ext uri="{FF2B5EF4-FFF2-40B4-BE49-F238E27FC236}">
-                <a16:creationId xmlns:a16="http://schemas.microsoft.com/office/drawing/2014/main" id="{C80505A2-5735-BE53-C813-CF409A4A33B7}"/>
+                <a16:creationId xmlns:a16="http://schemas.microsoft.com/office/drawing/2014/main" id="{A74611A8-33F7-C565-A8DC-8B9AC01C1DB1}"/>
               </a:ext>
             </a:extLst>
           </p:cNvPr>
@@ -712,7 +712,7 @@
           <a:bodyPr/>
           <a:lstStyle/>
           <a:p>
-            <a:fld id="{BED681DC-90D6-4908-8B41-16ED1ABBC1BC}" type="slidenum">
+            <a:fld id="{91787D38-685D-49A4-927F-FD1C1A5E76DF}" type="slidenum">
               <a:rPr lang="en-US" smtClean="0"/>
               <a:t>‹#›</a:t>
             </a:fld>
@@ -723,7 +723,7 @@
     </p:spTree>
     <p:extLst>
       <p:ext uri="{BB962C8B-B14F-4D97-AF65-F5344CB8AC3E}">
-        <p14:creationId xmlns:p14="http://schemas.microsoft.com/office/powerpoint/2010/main" val="1494144544"/>
+        <p14:creationId xmlns:p14="http://schemas.microsoft.com/office/powerpoint/2010/main" val="3983224332"/>
       </p:ext>
     </p:extLst>
   </p:cSld>
@@ -755,7 +755,7 @@
           <p:cNvPr id="2" name="Title 1">
             <a:extLst>
               <a:ext uri="{FF2B5EF4-FFF2-40B4-BE49-F238E27FC236}">
-                <a16:creationId xmlns:a16="http://schemas.microsoft.com/office/drawing/2014/main" id="{E35F1A40-A1EF-FE18-9417-20E068F71A5F}"/>
+                <a16:creationId xmlns:a16="http://schemas.microsoft.com/office/drawing/2014/main" id="{4803D97E-A759-0198-7747-3B5C2BAEBDB4}"/>
               </a:ext>
             </a:extLst>
           </p:cNvPr>
@@ -783,7 +783,7 @@
           <p:cNvPr id="3" name="Content Placeholder 2">
             <a:extLst>
               <a:ext uri="{FF2B5EF4-FFF2-40B4-BE49-F238E27FC236}">
-                <a16:creationId xmlns:a16="http://schemas.microsoft.com/office/drawing/2014/main" id="{FA54BEAD-F20D-0ADA-9839-D55F230DFD2C}"/>
+                <a16:creationId xmlns:a16="http://schemas.microsoft.com/office/drawing/2014/main" id="{4CA810EC-A91D-F4A1-9CB0-710F467B2B35}"/>
               </a:ext>
             </a:extLst>
           </p:cNvPr>
@@ -840,7 +840,7 @@
           <p:cNvPr id="4" name="Date Placeholder 3">
             <a:extLst>
               <a:ext uri="{FF2B5EF4-FFF2-40B4-BE49-F238E27FC236}">
-                <a16:creationId xmlns:a16="http://schemas.microsoft.com/office/drawing/2014/main" id="{67A2B095-EBB1-0AFC-4AFA-751287BBF6F8}"/>
+                <a16:creationId xmlns:a16="http://schemas.microsoft.com/office/drawing/2014/main" id="{25E8C1F6-B23F-5B87-57FD-1E06B808F650}"/>
               </a:ext>
             </a:extLst>
           </p:cNvPr>
@@ -856,9 +856,9 @@
           <a:bodyPr/>
           <a:lstStyle/>
           <a:p>
-            <a:fld id="{B6498013-008A-4316-B9B6-B44ADD31C3FE}" type="datetimeFigureOut">
+            <a:fld id="{B85B0049-ECB1-450D-8AAD-F92528287912}" type="datetimeFigureOut">
               <a:rPr lang="en-US" smtClean="0"/>
-              <a:t>10/28/2026</a:t>
+              <a:t>10/29/2026</a:t>
             </a:fld>
             <a:endParaRPr lang="en-US"/>
           </a:p>
@@ -869,7 +869,7 @@
           <p:cNvPr id="5" name="Footer Placeholder 4">
             <a:extLst>
               <a:ext uri="{FF2B5EF4-FFF2-40B4-BE49-F238E27FC236}">
-                <a16:creationId xmlns:a16="http://schemas.microsoft.com/office/drawing/2014/main" id="{6A0AE472-5B1A-91CE-E1E0-5347967C9C45}"/>
+                <a16:creationId xmlns:a16="http://schemas.microsoft.com/office/drawing/2014/main" id="{68A62B5A-B900-94E5-5A3C-71BB5603722A}"/>
               </a:ext>
             </a:extLst>
           </p:cNvPr>
@@ -894,7 +894,7 @@
           <p:cNvPr id="6" name="Slide Number Placeholder 5">
             <a:extLst>
               <a:ext uri="{FF2B5EF4-FFF2-40B4-BE49-F238E27FC236}">
-                <a16:creationId xmlns:a16="http://schemas.microsoft.com/office/drawing/2014/main" id="{F39CDE8F-6F23-83BD-6903-130FC771166A}"/>
+                <a16:creationId xmlns:a16="http://schemas.microsoft.com/office/drawing/2014/main" id="{E9C8C3E1-A650-7CC9-D7D6-869532BAB37C}"/>
               </a:ext>
             </a:extLst>
           </p:cNvPr>
@@ -910,7 +910,7 @@
           <a:bodyPr/>
           <a:lstStyle/>
           <a:p>
-            <a:fld id="{BED681DC-90D6-4908-8B41-16ED1ABBC1BC}" type="slidenum">
+            <a:fld id="{91787D38-685D-49A4-927F-FD1C1A5E76DF}" type="slidenum">
               <a:rPr lang="en-US" smtClean="0"/>
               <a:t>‹#›</a:t>
             </a:fld>
@@ -921,7 +921,7 @@
     </p:spTree>
     <p:extLst>
       <p:ext uri="{BB962C8B-B14F-4D97-AF65-F5344CB8AC3E}">
-        <p14:creationId xmlns:p14="http://schemas.microsoft.com/office/powerpoint/2010/main" val="2201175425"/>
+        <p14:creationId xmlns:p14="http://schemas.microsoft.com/office/powerpoint/2010/main" val="3666469611"/>
       </p:ext>
     </p:extLst>
   </p:cSld>
@@ -953,7 +953,7 @@
           <p:cNvPr id="2" name="Title 1">
             <a:extLst>
               <a:ext uri="{FF2B5EF4-FFF2-40B4-BE49-F238E27FC236}">
-                <a16:creationId xmlns:a16="http://schemas.microsoft.com/office/drawing/2014/main" id="{EB60401B-5606-681E-15DD-615AD17986ED}"/>
+                <a16:creationId xmlns:a16="http://schemas.microsoft.com/office/drawing/2014/main" id="{8F1DC968-EFF2-084C-91EB-E2566714EF43}"/>
               </a:ext>
             </a:extLst>
           </p:cNvPr>
@@ -990,7 +990,7 @@
           <p:cNvPr id="3" name="Text Placeholder 2">
             <a:extLst>
               <a:ext uri="{FF2B5EF4-FFF2-40B4-BE49-F238E27FC236}">
-                <a16:creationId xmlns:a16="http://schemas.microsoft.com/office/drawing/2014/main" id="{BC0F07E1-E95E-EC5F-50CE-3A20D2F57733}"/>
+                <a16:creationId xmlns:a16="http://schemas.microsoft.com/office/drawing/2014/main" id="{46BD18AB-FCEF-CB75-C2A2-755AE905CA29}"/>
               </a:ext>
             </a:extLst>
           </p:cNvPr>
@@ -1115,7 +1115,7 @@
           <p:cNvPr id="4" name="Date Placeholder 3">
             <a:extLst>
               <a:ext uri="{FF2B5EF4-FFF2-40B4-BE49-F238E27FC236}">
-                <a16:creationId xmlns:a16="http://schemas.microsoft.com/office/drawing/2014/main" id="{2CCC4C08-8109-0D11-7E00-0D751A7E96C4}"/>
+                <a16:creationId xmlns:a16="http://schemas.microsoft.com/office/drawing/2014/main" id="{DCF280E2-1279-0A08-42CC-41F3907F33D9}"/>
               </a:ext>
             </a:extLst>
           </p:cNvPr>
@@ -1131,9 +1131,9 @@
           <a:bodyPr/>
           <a:lstStyle/>
           <a:p>
-            <a:fld id="{B6498013-008A-4316-B9B6-B44ADD31C3FE}" type="datetimeFigureOut">
+            <a:fld id="{B85B0049-ECB1-450D-8AAD-F92528287912}" type="datetimeFigureOut">
               <a:rPr lang="en-US" smtClean="0"/>
-              <a:t>10/28/2026</a:t>
+              <a:t>10/29/2026</a:t>
             </a:fld>
             <a:endParaRPr lang="en-US"/>
           </a:p>
@@ -1144,7 +1144,7 @@
           <p:cNvPr id="5" name="Footer Placeholder 4">
             <a:extLst>
               <a:ext uri="{FF2B5EF4-FFF2-40B4-BE49-F238E27FC236}">
-                <a16:creationId xmlns:a16="http://schemas.microsoft.com/office/drawing/2014/main" id="{CD15E866-8A2E-7C2A-AFA9-6EB7173B86F8}"/>
+                <a16:creationId xmlns:a16="http://schemas.microsoft.com/office/drawing/2014/main" id="{9393EF9A-6442-4441-E267-DE3991DB35DF}"/>
               </a:ext>
             </a:extLst>
           </p:cNvPr>
@@ -1169,7 +1169,7 @@
           <p:cNvPr id="6" name="Slide Number Placeholder 5">
             <a:extLst>
               <a:ext uri="{FF2B5EF4-FFF2-40B4-BE49-F238E27FC236}">
-                <a16:creationId xmlns:a16="http://schemas.microsoft.com/office/drawing/2014/main" id="{92CE4F8A-87A8-C444-D574-D20182158ED2}"/>
+                <a16:creationId xmlns:a16="http://schemas.microsoft.com/office/drawing/2014/main" id="{6F05FC79-2826-BEE2-14D9-649550E9CB31}"/>
               </a:ext>
             </a:extLst>
           </p:cNvPr>
@@ -1185,7 +1185,7 @@
           <a:bodyPr/>
           <a:lstStyle/>
           <a:p>
-            <a:fld id="{BED681DC-90D6-4908-8B41-16ED1ABBC1BC}" type="slidenum">
+            <a:fld id="{91787D38-685D-49A4-927F-FD1C1A5E76DF}" type="slidenum">
               <a:rPr lang="en-US" smtClean="0"/>
               <a:t>‹#›</a:t>
             </a:fld>
@@ -1196,7 +1196,7 @@
     </p:spTree>
     <p:extLst>
       <p:ext uri="{BB962C8B-B14F-4D97-AF65-F5344CB8AC3E}">
-        <p14:creationId xmlns:p14="http://schemas.microsoft.com/office/powerpoint/2010/main" val="2646039912"/>
+        <p14:creationId xmlns:p14="http://schemas.microsoft.com/office/powerpoint/2010/main" val="523511304"/>
       </p:ext>
     </p:extLst>
   </p:cSld>
@@ -1228,7 +1228,7 @@
           <p:cNvPr id="2" name="Title 1">
             <a:extLst>
               <a:ext uri="{FF2B5EF4-FFF2-40B4-BE49-F238E27FC236}">
-                <a16:creationId xmlns:a16="http://schemas.microsoft.com/office/drawing/2014/main" id="{3E3AA0C6-6EEC-C6E9-5FD2-C50BC3239334}"/>
+                <a16:creationId xmlns:a16="http://schemas.microsoft.com/office/drawing/2014/main" id="{CA13799A-665D-E62C-E482-69726B4F2C36}"/>
               </a:ext>
             </a:extLst>
           </p:cNvPr>
@@ -1256,7 +1256,7 @@
           <p:cNvPr id="3" name="Content Placeholder 2">
             <a:extLst>
               <a:ext uri="{FF2B5EF4-FFF2-40B4-BE49-F238E27FC236}">
-                <a16:creationId xmlns:a16="http://schemas.microsoft.com/office/drawing/2014/main" id="{EBA9E055-8FCB-D72C-525B-06362EC8E98D}"/>
+                <a16:creationId xmlns:a16="http://schemas.microsoft.com/office/drawing/2014/main" id="{FE763540-304F-2A42-578D-13B7E8506303}"/>
               </a:ext>
             </a:extLst>
           </p:cNvPr>
@@ -1318,7 +1318,7 @@
           <p:cNvPr id="4" name="Content Placeholder 3">
             <a:extLst>
               <a:ext uri="{FF2B5EF4-FFF2-40B4-BE49-F238E27FC236}">
-                <a16:creationId xmlns:a16="http://schemas.microsoft.com/office/drawing/2014/main" id="{1737B2E7-E3FC-6F19-95F3-3A76B30D3B69}"/>
+                <a16:creationId xmlns:a16="http://schemas.microsoft.com/office/drawing/2014/main" id="{1475F1B7-561E-2E5A-1540-A0C2474F2327}"/>
               </a:ext>
             </a:extLst>
           </p:cNvPr>
@@ -1380,7 +1380,7 @@
           <p:cNvPr id="5" name="Date Placeholder 4">
             <a:extLst>
               <a:ext uri="{FF2B5EF4-FFF2-40B4-BE49-F238E27FC236}">
-                <a16:creationId xmlns:a16="http://schemas.microsoft.com/office/drawing/2014/main" id="{1852D116-1C06-BB37-D0EB-36BAF11050CA}"/>
+                <a16:creationId xmlns:a16="http://schemas.microsoft.com/office/drawing/2014/main" id="{7BDC14F8-FD76-5B59-8AF3-7FA71DDD3993}"/>
               </a:ext>
             </a:extLst>
           </p:cNvPr>
@@ -1396,9 +1396,9 @@
           <a:bodyPr/>
           <a:lstStyle/>
           <a:p>
-            <a:fld id="{B6498013-008A-4316-B9B6-B44ADD31C3FE}" type="datetimeFigureOut">
+            <a:fld id="{B85B0049-ECB1-450D-8AAD-F92528287912}" type="datetimeFigureOut">
               <a:rPr lang="en-US" smtClean="0"/>
-              <a:t>10/28/2026</a:t>
+              <a:t>10/29/2026</a:t>
             </a:fld>
             <a:endParaRPr lang="en-US"/>
           </a:p>
@@ -1409,7 +1409,7 @@
           <p:cNvPr id="6" name="Footer Placeholder 5">
             <a:extLst>
               <a:ext uri="{FF2B5EF4-FFF2-40B4-BE49-F238E27FC236}">
-                <a16:creationId xmlns:a16="http://schemas.microsoft.com/office/drawing/2014/main" id="{48E37036-AE38-E88D-220B-42907B4ABF2A}"/>
+                <a16:creationId xmlns:a16="http://schemas.microsoft.com/office/drawing/2014/main" id="{2A931C8E-7CDC-5913-7B23-66287ECAD5E6}"/>
               </a:ext>
             </a:extLst>
           </p:cNvPr>
@@ -1434,7 +1434,7 @@
           <p:cNvPr id="7" name="Slide Number Placeholder 6">
             <a:extLst>
               <a:ext uri="{FF2B5EF4-FFF2-40B4-BE49-F238E27FC236}">
-                <a16:creationId xmlns:a16="http://schemas.microsoft.com/office/drawing/2014/main" id="{559FE545-CE0E-E757-C3C7-CC2C57822769}"/>
+                <a16:creationId xmlns:a16="http://schemas.microsoft.com/office/drawing/2014/main" id="{8E97774C-B793-FDBB-9713-C14EFB5CAA21}"/>
               </a:ext>
             </a:extLst>
           </p:cNvPr>
@@ -1450,7 +1450,7 @@
           <a:bodyPr/>
           <a:lstStyle/>
           <a:p>
-            <a:fld id="{BED681DC-90D6-4908-8B41-16ED1ABBC1BC}" type="slidenum">
+            <a:fld id="{91787D38-685D-49A4-927F-FD1C1A5E76DF}" type="slidenum">
               <a:rPr lang="en-US" smtClean="0"/>
               <a:t>‹#›</a:t>
             </a:fld>
@@ -1461,7 +1461,7 @@
     </p:spTree>
     <p:extLst>
       <p:ext uri="{BB962C8B-B14F-4D97-AF65-F5344CB8AC3E}">
-        <p14:creationId xmlns:p14="http://schemas.microsoft.com/office/powerpoint/2010/main" val="3404114388"/>
+        <p14:creationId xmlns:p14="http://schemas.microsoft.com/office/powerpoint/2010/main" val="591856536"/>
       </p:ext>
     </p:extLst>
   </p:cSld>
@@ -1493,7 +1493,7 @@
           <p:cNvPr id="2" name="Title 1">
             <a:extLst>
               <a:ext uri="{FF2B5EF4-FFF2-40B4-BE49-F238E27FC236}">
-                <a16:creationId xmlns:a16="http://schemas.microsoft.com/office/drawing/2014/main" id="{82F3664D-5940-9AE6-0DCA-177FDCDBD82A}"/>
+                <a16:creationId xmlns:a16="http://schemas.microsoft.com/office/drawing/2014/main" id="{C8902710-23DB-EA7C-ED53-70856AF41E8C}"/>
               </a:ext>
             </a:extLst>
           </p:cNvPr>
@@ -1526,7 +1526,7 @@
           <p:cNvPr id="3" name="Text Placeholder 2">
             <a:extLst>
               <a:ext uri="{FF2B5EF4-FFF2-40B4-BE49-F238E27FC236}">
-                <a16:creationId xmlns:a16="http://schemas.microsoft.com/office/drawing/2014/main" id="{C4DE87FB-325D-B4BC-6A17-129AB22312FF}"/>
+                <a16:creationId xmlns:a16="http://schemas.microsoft.com/office/drawing/2014/main" id="{D40F2F9C-3840-1714-66FE-DD6C6379B20C}"/>
               </a:ext>
             </a:extLst>
           </p:cNvPr>
@@ -1597,7 +1597,7 @@
           <p:cNvPr id="4" name="Content Placeholder 3">
             <a:extLst>
               <a:ext uri="{FF2B5EF4-FFF2-40B4-BE49-F238E27FC236}">
-                <a16:creationId xmlns:a16="http://schemas.microsoft.com/office/drawing/2014/main" id="{1B365B74-FE46-BE07-97B8-60042A250A77}"/>
+                <a16:creationId xmlns:a16="http://schemas.microsoft.com/office/drawing/2014/main" id="{666B5271-6A68-2CB5-42C2-6829A0FDD82B}"/>
               </a:ext>
             </a:extLst>
           </p:cNvPr>
@@ -1659,7 +1659,7 @@
           <p:cNvPr id="5" name="Text Placeholder 4">
             <a:extLst>
               <a:ext uri="{FF2B5EF4-FFF2-40B4-BE49-F238E27FC236}">
-                <a16:creationId xmlns:a16="http://schemas.microsoft.com/office/drawing/2014/main" id="{9CA3DBA1-4720-3D38-0517-67C6FEC58C54}"/>
+                <a16:creationId xmlns:a16="http://schemas.microsoft.com/office/drawing/2014/main" id="{4367157C-ED43-D2FC-F937-F51143AE6FAD}"/>
               </a:ext>
             </a:extLst>
           </p:cNvPr>
@@ -1730,7 +1730,7 @@
           <p:cNvPr id="6" name="Content Placeholder 5">
             <a:extLst>
               <a:ext uri="{FF2B5EF4-FFF2-40B4-BE49-F238E27FC236}">
-                <a16:creationId xmlns:a16="http://schemas.microsoft.com/office/drawing/2014/main" id="{C1427C95-6C78-9A94-5DA7-9C08ADF793FD}"/>
+                <a16:creationId xmlns:a16="http://schemas.microsoft.com/office/drawing/2014/main" id="{E8179AA3-F9FF-CEFF-4B79-C6D58492B32A}"/>
               </a:ext>
             </a:extLst>
           </p:cNvPr>
@@ -1792,7 +1792,7 @@
           <p:cNvPr id="7" name="Date Placeholder 6">
             <a:extLst>
               <a:ext uri="{FF2B5EF4-FFF2-40B4-BE49-F238E27FC236}">
-                <a16:creationId xmlns:a16="http://schemas.microsoft.com/office/drawing/2014/main" id="{838CFB9A-D02B-D70D-5308-E2D89231E68C}"/>
+                <a16:creationId xmlns:a16="http://schemas.microsoft.com/office/drawing/2014/main" id="{96C32218-DB11-3546-DA8F-6F1BA6CE8588}"/>
               </a:ext>
             </a:extLst>
           </p:cNvPr>
@@ -1808,9 +1808,9 @@
           <a:bodyPr/>
           <a:lstStyle/>
           <a:p>
-            <a:fld id="{B6498013-008A-4316-B9B6-B44ADD31C3FE}" type="datetimeFigureOut">
+            <a:fld id="{B85B0049-ECB1-450D-8AAD-F92528287912}" type="datetimeFigureOut">
               <a:rPr lang="en-US" smtClean="0"/>
-              <a:t>10/28/2026</a:t>
+              <a:t>10/29/2026</a:t>
             </a:fld>
             <a:endParaRPr lang="en-US"/>
           </a:p>
@@ -1821,7 +1821,7 @@
           <p:cNvPr id="8" name="Footer Placeholder 7">
             <a:extLst>
               <a:ext uri="{FF2B5EF4-FFF2-40B4-BE49-F238E27FC236}">
-                <a16:creationId xmlns:a16="http://schemas.microsoft.com/office/drawing/2014/main" id="{74A520C7-D58B-03A8-E292-1B6201441265}"/>
+                <a16:creationId xmlns:a16="http://schemas.microsoft.com/office/drawing/2014/main" id="{23D03FC9-08EA-CD0A-92C4-CCC0B5A704F9}"/>
               </a:ext>
             </a:extLst>
           </p:cNvPr>
@@ -1846,7 +1846,7 @@
           <p:cNvPr id="9" name="Slide Number Placeholder 8">
             <a:extLst>
               <a:ext uri="{FF2B5EF4-FFF2-40B4-BE49-F238E27FC236}">
-                <a16:creationId xmlns:a16="http://schemas.microsoft.com/office/drawing/2014/main" id="{E06608BE-32DD-2994-D358-6964080556D8}"/>
+                <a16:creationId xmlns:a16="http://schemas.microsoft.com/office/drawing/2014/main" id="{341174B2-6BA1-AB4E-2A42-B65110DA8583}"/>
               </a:ext>
             </a:extLst>
           </p:cNvPr>
@@ -1862,7 +1862,7 @@
           <a:bodyPr/>
           <a:lstStyle/>
           <a:p>
-            <a:fld id="{BED681DC-90D6-4908-8B41-16ED1ABBC1BC}" type="slidenum">
+            <a:fld id="{91787D38-685D-49A4-927F-FD1C1A5E76DF}" type="slidenum">
               <a:rPr lang="en-US" smtClean="0"/>
               <a:t>‹#›</a:t>
             </a:fld>
@@ -1873,7 +1873,7 @@
     </p:spTree>
     <p:extLst>
       <p:ext uri="{BB962C8B-B14F-4D97-AF65-F5344CB8AC3E}">
-        <p14:creationId xmlns:p14="http://schemas.microsoft.com/office/powerpoint/2010/main" val="137944064"/>
+        <p14:creationId xmlns:p14="http://schemas.microsoft.com/office/powerpoint/2010/main" val="1359213808"/>
       </p:ext>
     </p:extLst>
   </p:cSld>
@@ -1905,7 +1905,7 @@
           <p:cNvPr id="2" name="Title 1">
             <a:extLst>
               <a:ext uri="{FF2B5EF4-FFF2-40B4-BE49-F238E27FC236}">
-                <a16:creationId xmlns:a16="http://schemas.microsoft.com/office/drawing/2014/main" id="{08014566-367E-451E-8A22-8FE973B98A43}"/>
+                <a16:creationId xmlns:a16="http://schemas.microsoft.com/office/drawing/2014/main" id="{512B5DC4-24AE-BBC0-295C-9477FF427BB0}"/>
               </a:ext>
             </a:extLst>
           </p:cNvPr>
@@ -1933,7 +1933,7 @@
           <p:cNvPr id="3" name="Date Placeholder 2">
             <a:extLst>
               <a:ext uri="{FF2B5EF4-FFF2-40B4-BE49-F238E27FC236}">
-                <a16:creationId xmlns:a16="http://schemas.microsoft.com/office/drawing/2014/main" id="{F67DC178-303A-8BAD-3B9B-D0BBB38A9E37}"/>
+                <a16:creationId xmlns:a16="http://schemas.microsoft.com/office/drawing/2014/main" id="{CA8480A1-2F90-746A-92AE-DECF29D51907}"/>
               </a:ext>
             </a:extLst>
           </p:cNvPr>
@@ -1949,9 +1949,9 @@
           <a:bodyPr/>
           <a:lstStyle/>
           <a:p>
-            <a:fld id="{B6498013-008A-4316-B9B6-B44ADD31C3FE}" type="datetimeFigureOut">
+            <a:fld id="{B85B0049-ECB1-450D-8AAD-F92528287912}" type="datetimeFigureOut">
               <a:rPr lang="en-US" smtClean="0"/>
-              <a:t>10/28/2026</a:t>
+              <a:t>10/29/2026</a:t>
             </a:fld>
             <a:endParaRPr lang="en-US"/>
           </a:p>
@@ -1962,7 +1962,7 @@
           <p:cNvPr id="4" name="Footer Placeholder 3">
             <a:extLst>
               <a:ext uri="{FF2B5EF4-FFF2-40B4-BE49-F238E27FC236}">
-                <a16:creationId xmlns:a16="http://schemas.microsoft.com/office/drawing/2014/main" id="{50769F74-3C9E-CD93-7A8D-6E10079210B7}"/>
+                <a16:creationId xmlns:a16="http://schemas.microsoft.com/office/drawing/2014/main" id="{967CC830-51DF-6828-B287-6C90A136A4CA}"/>
               </a:ext>
             </a:extLst>
           </p:cNvPr>
@@ -1987,7 +1987,7 @@
           <p:cNvPr id="5" name="Slide Number Placeholder 4">
             <a:extLst>
               <a:ext uri="{FF2B5EF4-FFF2-40B4-BE49-F238E27FC236}">
-                <a16:creationId xmlns:a16="http://schemas.microsoft.com/office/drawing/2014/main" id="{26AB5B74-5643-1D7B-C42D-D1BB0A33A4B9}"/>
+                <a16:creationId xmlns:a16="http://schemas.microsoft.com/office/drawing/2014/main" id="{41718151-51FD-52E2-46A7-C13F416FBA0F}"/>
               </a:ext>
             </a:extLst>
           </p:cNvPr>
@@ -2003,7 +2003,7 @@
           <a:bodyPr/>
           <a:lstStyle/>
           <a:p>
-            <a:fld id="{BED681DC-90D6-4908-8B41-16ED1ABBC1BC}" type="slidenum">
+            <a:fld id="{91787D38-685D-49A4-927F-FD1C1A5E76DF}" type="slidenum">
               <a:rPr lang="en-US" smtClean="0"/>
               <a:t>‹#›</a:t>
             </a:fld>
@@ -2014,7 +2014,7 @@
     </p:spTree>
     <p:extLst>
       <p:ext uri="{BB962C8B-B14F-4D97-AF65-F5344CB8AC3E}">
-        <p14:creationId xmlns:p14="http://schemas.microsoft.com/office/powerpoint/2010/main" val="3524528972"/>
+        <p14:creationId xmlns:p14="http://schemas.microsoft.com/office/powerpoint/2010/main" val="3713351551"/>
       </p:ext>
     </p:extLst>
   </p:cSld>
@@ -2046,7 +2046,7 @@
           <p:cNvPr id="2" name="Date Placeholder 1">
             <a:extLst>
               <a:ext uri="{FF2B5EF4-FFF2-40B4-BE49-F238E27FC236}">
-                <a16:creationId xmlns:a16="http://schemas.microsoft.com/office/drawing/2014/main" id="{3E29ABBA-0C0D-7F8C-C494-4DBCA9DD73D1}"/>
+                <a16:creationId xmlns:a16="http://schemas.microsoft.com/office/drawing/2014/main" id="{B7E4BC63-5604-16F2-9966-627A40059207}"/>
               </a:ext>
             </a:extLst>
           </p:cNvPr>
@@ -2062,9 +2062,9 @@
           <a:bodyPr/>
           <a:lstStyle/>
           <a:p>
-            <a:fld id="{B6498013-008A-4316-B9B6-B44ADD31C3FE}" type="datetimeFigureOut">
+            <a:fld id="{B85B0049-ECB1-450D-8AAD-F92528287912}" type="datetimeFigureOut">
               <a:rPr lang="en-US" smtClean="0"/>
-              <a:t>10/28/2026</a:t>
+              <a:t>10/29/2026</a:t>
             </a:fld>
             <a:endParaRPr lang="en-US"/>
           </a:p>
@@ -2075,7 +2075,7 @@
           <p:cNvPr id="3" name="Footer Placeholder 2">
             <a:extLst>
               <a:ext uri="{FF2B5EF4-FFF2-40B4-BE49-F238E27FC236}">
-                <a16:creationId xmlns:a16="http://schemas.microsoft.com/office/drawing/2014/main" id="{BBA456C2-9844-46A0-DE53-86BDD429D14F}"/>
+                <a16:creationId xmlns:a16="http://schemas.microsoft.com/office/drawing/2014/main" id="{D636E5EB-B836-74AC-9B42-E0A8835FCBBD}"/>
               </a:ext>
             </a:extLst>
           </p:cNvPr>
@@ -2100,7 +2100,7 @@
           <p:cNvPr id="4" name="Slide Number Placeholder 3">
             <a:extLst>
               <a:ext uri="{FF2B5EF4-FFF2-40B4-BE49-F238E27FC236}">
-                <a16:creationId xmlns:a16="http://schemas.microsoft.com/office/drawing/2014/main" id="{B1BE4F51-FC64-E939-E62C-21B6289E682C}"/>
+                <a16:creationId xmlns:a16="http://schemas.microsoft.com/office/drawing/2014/main" id="{AA42BDD9-8150-E2C2-5E7C-E95F9E111C63}"/>
               </a:ext>
             </a:extLst>
           </p:cNvPr>
@@ -2116,7 +2116,7 @@
           <a:bodyPr/>
           <a:lstStyle/>
           <a:p>
-            <a:fld id="{BED681DC-90D6-4908-8B41-16ED1ABBC1BC}" type="slidenum">
+            <a:fld id="{91787D38-685D-49A4-927F-FD1C1A5E76DF}" type="slidenum">
               <a:rPr lang="en-US" smtClean="0"/>
               <a:t>‹#›</a:t>
             </a:fld>
@@ -2127,7 +2127,7 @@
     </p:spTree>
     <p:extLst>
       <p:ext uri="{BB962C8B-B14F-4D97-AF65-F5344CB8AC3E}">
-        <p14:creationId xmlns:p14="http://schemas.microsoft.com/office/powerpoint/2010/main" val="1287251292"/>
+        <p14:creationId xmlns:p14="http://schemas.microsoft.com/office/powerpoint/2010/main" val="2187776877"/>
       </p:ext>
     </p:extLst>
   </p:cSld>
@@ -2159,7 +2159,7 @@
           <p:cNvPr id="2" name="Title 1">
             <a:extLst>
               <a:ext uri="{FF2B5EF4-FFF2-40B4-BE49-F238E27FC236}">
-                <a16:creationId xmlns:a16="http://schemas.microsoft.com/office/drawing/2014/main" id="{45D993E5-6DF0-A35F-9E3F-874A034276FB}"/>
+                <a16:creationId xmlns:a16="http://schemas.microsoft.com/office/drawing/2014/main" id="{9761A91E-239F-72E2-E969-BC88BFCD0577}"/>
               </a:ext>
             </a:extLst>
           </p:cNvPr>
@@ -2196,7 +2196,7 @@
           <p:cNvPr id="3" name="Content Placeholder 2">
             <a:extLst>
               <a:ext uri="{FF2B5EF4-FFF2-40B4-BE49-F238E27FC236}">
-                <a16:creationId xmlns:a16="http://schemas.microsoft.com/office/drawing/2014/main" id="{6B7CB16C-0358-BF50-32F3-F5C0805DA49F}"/>
+                <a16:creationId xmlns:a16="http://schemas.microsoft.com/office/drawing/2014/main" id="{EB97F21A-EF4B-EA0A-C1D1-FED3C1B77E95}"/>
               </a:ext>
             </a:extLst>
           </p:cNvPr>
@@ -2286,7 +2286,7 @@
           <p:cNvPr id="4" name="Text Placeholder 3">
             <a:extLst>
               <a:ext uri="{FF2B5EF4-FFF2-40B4-BE49-F238E27FC236}">
-                <a16:creationId xmlns:a16="http://schemas.microsoft.com/office/drawing/2014/main" id="{F97CDCEF-DFF9-6799-0C9C-A04D036849D8}"/>
+                <a16:creationId xmlns:a16="http://schemas.microsoft.com/office/drawing/2014/main" id="{7FFEFA5F-E061-1D2A-D5FD-EB34CA74A835}"/>
               </a:ext>
             </a:extLst>
           </p:cNvPr>
@@ -2357,7 +2357,7 @@
           <p:cNvPr id="5" name="Date Placeholder 4">
             <a:extLst>
               <a:ext uri="{FF2B5EF4-FFF2-40B4-BE49-F238E27FC236}">
-                <a16:creationId xmlns:a16="http://schemas.microsoft.com/office/drawing/2014/main" id="{7F6F1E3E-0883-43F7-685B-6D4823908E8C}"/>
+                <a16:creationId xmlns:a16="http://schemas.microsoft.com/office/drawing/2014/main" id="{95007128-8952-6926-8835-9AB47986C0FA}"/>
               </a:ext>
             </a:extLst>
           </p:cNvPr>
@@ -2373,9 +2373,9 @@
           <a:bodyPr/>
           <a:lstStyle/>
           <a:p>
-            <a:fld id="{B6498013-008A-4316-B9B6-B44ADD31C3FE}" type="datetimeFigureOut">
+            <a:fld id="{B85B0049-ECB1-450D-8AAD-F92528287912}" type="datetimeFigureOut">
               <a:rPr lang="en-US" smtClean="0"/>
-              <a:t>10/28/2026</a:t>
+              <a:t>10/29/2026</a:t>
             </a:fld>
             <a:endParaRPr lang="en-US"/>
           </a:p>
@@ -2386,7 +2386,7 @@
           <p:cNvPr id="6" name="Footer Placeholder 5">
             <a:extLst>
               <a:ext uri="{FF2B5EF4-FFF2-40B4-BE49-F238E27FC236}">
-                <a16:creationId xmlns:a16="http://schemas.microsoft.com/office/drawing/2014/main" id="{4ED05637-AFEA-14EC-253D-33CA12088350}"/>
+                <a16:creationId xmlns:a16="http://schemas.microsoft.com/office/drawing/2014/main" id="{F939BCED-F14C-1F4F-CA9C-508D3424AD43}"/>
               </a:ext>
             </a:extLst>
           </p:cNvPr>
@@ -2411,7 +2411,7 @@
           <p:cNvPr id="7" name="Slide Number Placeholder 6">
             <a:extLst>
               <a:ext uri="{FF2B5EF4-FFF2-40B4-BE49-F238E27FC236}">
-                <a16:creationId xmlns:a16="http://schemas.microsoft.com/office/drawing/2014/main" id="{83DF9068-F72F-B3A4-D0F7-A94D71120EA1}"/>
+                <a16:creationId xmlns:a16="http://schemas.microsoft.com/office/drawing/2014/main" id="{0D66C61A-9923-E699-7EF0-B357BED53C28}"/>
               </a:ext>
             </a:extLst>
           </p:cNvPr>
@@ -2427,7 +2427,7 @@
           <a:bodyPr/>
           <a:lstStyle/>
           <a:p>
-            <a:fld id="{BED681DC-90D6-4908-8B41-16ED1ABBC1BC}" type="slidenum">
+            <a:fld id="{91787D38-685D-49A4-927F-FD1C1A5E76DF}" type="slidenum">
               <a:rPr lang="en-US" smtClean="0"/>
               <a:t>‹#›</a:t>
             </a:fld>
@@ -2438,7 +2438,7 @@
     </p:spTree>
     <p:extLst>
       <p:ext uri="{BB962C8B-B14F-4D97-AF65-F5344CB8AC3E}">
-        <p14:creationId xmlns:p14="http://schemas.microsoft.com/office/powerpoint/2010/main" val="126502205"/>
+        <p14:creationId xmlns:p14="http://schemas.microsoft.com/office/powerpoint/2010/main" val="773070994"/>
       </p:ext>
     </p:extLst>
   </p:cSld>
@@ -2470,7 +2470,7 @@
           <p:cNvPr id="2" name="Title 1">
             <a:extLst>
               <a:ext uri="{FF2B5EF4-FFF2-40B4-BE49-F238E27FC236}">
-                <a16:creationId xmlns:a16="http://schemas.microsoft.com/office/drawing/2014/main" id="{8875BB93-6B60-C3F7-12C8-2139CB5B295C}"/>
+                <a16:creationId xmlns:a16="http://schemas.microsoft.com/office/drawing/2014/main" id="{5EE13C96-E06F-9491-329E-FE410BA760D1}"/>
               </a:ext>
             </a:extLst>
           </p:cNvPr>
@@ -2507,7 +2507,7 @@
           <p:cNvPr id="3" name="Picture Placeholder 2">
             <a:extLst>
               <a:ext uri="{FF2B5EF4-FFF2-40B4-BE49-F238E27FC236}">
-                <a16:creationId xmlns:a16="http://schemas.microsoft.com/office/drawing/2014/main" id="{9CFA2355-5693-09EF-1443-BF1852E0CBDA}"/>
+                <a16:creationId xmlns:a16="http://schemas.microsoft.com/office/drawing/2014/main" id="{B49291BF-923A-6F4F-D612-5473578BE163}"/>
               </a:ext>
             </a:extLst>
           </p:cNvPr>
@@ -2574,7 +2574,7 @@
           <p:cNvPr id="4" name="Text Placeholder 3">
             <a:extLst>
               <a:ext uri="{FF2B5EF4-FFF2-40B4-BE49-F238E27FC236}">
-                <a16:creationId xmlns:a16="http://schemas.microsoft.com/office/drawing/2014/main" id="{3D2801A0-2EB3-5CD5-82B6-0B5C7398120E}"/>
+                <a16:creationId xmlns:a16="http://schemas.microsoft.com/office/drawing/2014/main" id="{0057F227-4DB0-0D41-679E-CB7C2AA792DC}"/>
               </a:ext>
             </a:extLst>
           </p:cNvPr>
@@ -2645,7 +2645,7 @@
           <p:cNvPr id="5" name="Date Placeholder 4">
             <a:extLst>
               <a:ext uri="{FF2B5EF4-FFF2-40B4-BE49-F238E27FC236}">
-                <a16:creationId xmlns:a16="http://schemas.microsoft.com/office/drawing/2014/main" id="{24041974-CC23-E5DE-D4CA-0BFEC9D475FD}"/>
+                <a16:creationId xmlns:a16="http://schemas.microsoft.com/office/drawing/2014/main" id="{C950894A-A52C-D6E1-9428-2EFADB70D15F}"/>
               </a:ext>
             </a:extLst>
           </p:cNvPr>
@@ -2661,9 +2661,9 @@
           <a:bodyPr/>
           <a:lstStyle/>
           <a:p>
-            <a:fld id="{B6498013-008A-4316-B9B6-B44ADD31C3FE}" type="datetimeFigureOut">
+            <a:fld id="{B85B0049-ECB1-450D-8AAD-F92528287912}" type="datetimeFigureOut">
               <a:rPr lang="en-US" smtClean="0"/>
-              <a:t>10/28/2026</a:t>
+              <a:t>10/29/2026</a:t>
             </a:fld>
             <a:endParaRPr lang="en-US"/>
           </a:p>
@@ -2674,7 +2674,7 @@
           <p:cNvPr id="6" name="Footer Placeholder 5">
             <a:extLst>
               <a:ext uri="{FF2B5EF4-FFF2-40B4-BE49-F238E27FC236}">
-                <a16:creationId xmlns:a16="http://schemas.microsoft.com/office/drawing/2014/main" id="{2A944DFB-96BF-4B11-5ADE-C369674BBE4C}"/>
+                <a16:creationId xmlns:a16="http://schemas.microsoft.com/office/drawing/2014/main" id="{F54939DC-FF72-10F9-C670-3A00D7B21800}"/>
               </a:ext>
             </a:extLst>
           </p:cNvPr>
@@ -2699,7 +2699,7 @@
           <p:cNvPr id="7" name="Slide Number Placeholder 6">
             <a:extLst>
               <a:ext uri="{FF2B5EF4-FFF2-40B4-BE49-F238E27FC236}">
-                <a16:creationId xmlns:a16="http://schemas.microsoft.com/office/drawing/2014/main" id="{BE7584DC-667B-26E8-7C89-8703660C7511}"/>
+                <a16:creationId xmlns:a16="http://schemas.microsoft.com/office/drawing/2014/main" id="{88D2530E-622A-EBB9-6E8F-011518A8C213}"/>
               </a:ext>
             </a:extLst>
           </p:cNvPr>
@@ -2715,7 +2715,7 @@
           <a:bodyPr/>
           <a:lstStyle/>
           <a:p>
-            <a:fld id="{BED681DC-90D6-4908-8B41-16ED1ABBC1BC}" type="slidenum">
+            <a:fld id="{91787D38-685D-49A4-927F-FD1C1A5E76DF}" type="slidenum">
               <a:rPr lang="en-US" smtClean="0"/>
               <a:t>‹#›</a:t>
             </a:fld>
@@ -2726,7 +2726,7 @@
     </p:spTree>
     <p:extLst>
       <p:ext uri="{BB962C8B-B14F-4D97-AF65-F5344CB8AC3E}">
-        <p14:creationId xmlns:p14="http://schemas.microsoft.com/office/powerpoint/2010/main" val="1615349295"/>
+        <p14:creationId xmlns:p14="http://schemas.microsoft.com/office/powerpoint/2010/main" val="1616788171"/>
       </p:ext>
     </p:extLst>
   </p:cSld>
@@ -2763,7 +2763,7 @@
           <p:cNvPr id="2" name="Title Placeholder 1">
             <a:extLst>
               <a:ext uri="{FF2B5EF4-FFF2-40B4-BE49-F238E27FC236}">
-                <a16:creationId xmlns:a16="http://schemas.microsoft.com/office/drawing/2014/main" id="{894402C1-B108-7AA4-9495-191C2EAAF6BA}"/>
+                <a16:creationId xmlns:a16="http://schemas.microsoft.com/office/drawing/2014/main" id="{36C94D17-0235-2C10-ACE0-23D0988BBE43}"/>
               </a:ext>
             </a:extLst>
           </p:cNvPr>
@@ -2801,7 +2801,7 @@
           <p:cNvPr id="3" name="Text Placeholder 2">
             <a:extLst>
               <a:ext uri="{FF2B5EF4-FFF2-40B4-BE49-F238E27FC236}">
-                <a16:creationId xmlns:a16="http://schemas.microsoft.com/office/drawing/2014/main" id="{EA2371FA-1C62-A1CD-CAEB-8E4F326D043C}"/>
+                <a16:creationId xmlns:a16="http://schemas.microsoft.com/office/drawing/2014/main" id="{285BAB12-6F4D-3C52-8878-36537C8D2991}"/>
               </a:ext>
             </a:extLst>
           </p:cNvPr>
@@ -2868,7 +2868,7 @@
           <p:cNvPr id="4" name="Date Placeholder 3">
             <a:extLst>
               <a:ext uri="{FF2B5EF4-FFF2-40B4-BE49-F238E27FC236}">
-                <a16:creationId xmlns:a16="http://schemas.microsoft.com/office/drawing/2014/main" id="{8C24D9CA-6667-44F2-6C49-B9A1F14063A8}"/>
+                <a16:creationId xmlns:a16="http://schemas.microsoft.com/office/drawing/2014/main" id="{4B7046E5-4CFF-651D-6566-3182E9C5CFA1}"/>
               </a:ext>
             </a:extLst>
           </p:cNvPr>
@@ -2902,9 +2902,9 @@
             </a:lvl1pPr>
           </a:lstStyle>
           <a:p>
-            <a:fld id="{B6498013-008A-4316-B9B6-B44ADD31C3FE}" type="datetimeFigureOut">
+            <a:fld id="{B85B0049-ECB1-450D-8AAD-F92528287912}" type="datetimeFigureOut">
               <a:rPr lang="en-US" smtClean="0"/>
-              <a:t>10/28/2026</a:t>
+              <a:t>10/29/2026</a:t>
             </a:fld>
             <a:endParaRPr lang="en-US"/>
           </a:p>
@@ -2915,7 +2915,7 @@
           <p:cNvPr id="5" name="Footer Placeholder 4">
             <a:extLst>
               <a:ext uri="{FF2B5EF4-FFF2-40B4-BE49-F238E27FC236}">
-                <a16:creationId xmlns:a16="http://schemas.microsoft.com/office/drawing/2014/main" id="{1F653EC6-E261-A968-3BA6-970162250BCF}"/>
+                <a16:creationId xmlns:a16="http://schemas.microsoft.com/office/drawing/2014/main" id="{82F2E15D-A0F7-75E5-150A-902CF7500263}"/>
               </a:ext>
             </a:extLst>
           </p:cNvPr>
@@ -2958,7 +2958,7 @@
           <p:cNvPr id="6" name="Slide Number Placeholder 5">
             <a:extLst>
               <a:ext uri="{FF2B5EF4-FFF2-40B4-BE49-F238E27FC236}">
-                <a16:creationId xmlns:a16="http://schemas.microsoft.com/office/drawing/2014/main" id="{E0F742AF-5859-D398-CE92-F3D7F4CB0677}"/>
+                <a16:creationId xmlns:a16="http://schemas.microsoft.com/office/drawing/2014/main" id="{C4233CBD-FD14-0F52-4FE4-CBEBDFD9677C}"/>
               </a:ext>
             </a:extLst>
           </p:cNvPr>
@@ -2992,7 +2992,7 @@
             </a:lvl1pPr>
           </a:lstStyle>
           <a:p>
-            <a:fld id="{BED681DC-90D6-4908-8B41-16ED1ABBC1BC}" type="slidenum">
+            <a:fld id="{91787D38-685D-49A4-927F-FD1C1A5E76DF}" type="slidenum">
               <a:rPr lang="en-US" smtClean="0"/>
               <a:t>‹#›</a:t>
             </a:fld>
@@ -3003,7 +3003,7 @@
     </p:spTree>
     <p:extLst>
       <p:ext uri="{BB962C8B-B14F-4D97-AF65-F5344CB8AC3E}">
-        <p14:creationId xmlns:p14="http://schemas.microsoft.com/office/powerpoint/2010/main" val="620731672"/>
+        <p14:creationId xmlns:p14="http://schemas.microsoft.com/office/powerpoint/2010/main" val="3758725504"/>
       </p:ext>
     </p:extLst>
   </p:cSld>
@@ -3334,7 +3334,7 @@
           <p:cNvPr id="3" name="Picture 2">
             <a:extLst>
               <a:ext uri="{FF2B5EF4-FFF2-40B4-BE49-F238E27FC236}">
-                <a16:creationId xmlns:a16="http://schemas.microsoft.com/office/drawing/2014/main" id="{4286A180-0B6E-1D2A-89B1-6A245A1AEDA4}"/>
+                <a16:creationId xmlns:a16="http://schemas.microsoft.com/office/drawing/2014/main" id="{2BA69377-B0DB-AC60-2AB9-656FE11F7864}"/>
               </a:ext>
             </a:extLst>
           </p:cNvPr>
@@ -3370,7 +3370,7 @@
           <p:cNvPr id="4" name="Rectangle 3">
             <a:extLst>
               <a:ext uri="{FF2B5EF4-FFF2-40B4-BE49-F238E27FC236}">
-                <a16:creationId xmlns:a16="http://schemas.microsoft.com/office/drawing/2014/main" id="{6F635E43-C96B-82A1-8C18-2E06FF78F072}"/>
+                <a16:creationId xmlns:a16="http://schemas.microsoft.com/office/drawing/2014/main" id="{5060AB2B-F392-2301-E87B-82F43303942D}"/>
               </a:ext>
             </a:extLst>
           </p:cNvPr>
@@ -3380,7 +3380,7 @@
         <p:spPr>
           <a:xfrm>
             <a:off x="0" y="0"/>
-            <a:ext cx="5328031" cy="3810000"/>
+            <a:ext cx="5328031" cy="4038600"/>
           </a:xfrm>
           <a:prstGeom prst="rect">
             <a:avLst/>
@@ -3395,9 +3395,9 @@
                   <a:alpha val="0"/>
                 </a:srgbClr>
               </a:gs>
-              <a:gs pos="55000">
+              <a:gs pos="72000">
                 <a:srgbClr val="05070D">
-                  <a:alpha val="85000"/>
+                  <a:alpha val="80000"/>
                 </a:srgbClr>
               </a:gs>
             </a:gsLst>
@@ -3441,7 +3441,7 @@
           <p:cNvPr id="6" name="Picture 5">
             <a:extLst>
               <a:ext uri="{FF2B5EF4-FFF2-40B4-BE49-F238E27FC236}">
-                <a16:creationId xmlns:a16="http://schemas.microsoft.com/office/drawing/2014/main" id="{64FAF7AA-C00F-B7E2-11E6-C50309D726A5}"/>
+                <a16:creationId xmlns:a16="http://schemas.microsoft.com/office/drawing/2014/main" id="{A459BAB9-F32A-7242-E06A-0033E183CF22}"/>
               </a:ext>
             </a:extLst>
           </p:cNvPr>
@@ -3477,7 +3477,7 @@
           <p:cNvPr id="7" name="TextBox 6">
             <a:extLst>
               <a:ext uri="{FF2B5EF4-FFF2-40B4-BE49-F238E27FC236}">
-                <a16:creationId xmlns:a16="http://schemas.microsoft.com/office/drawing/2014/main" id="{B3045421-1DDB-C29F-1B27-1665E971ED06}"/>
+                <a16:creationId xmlns:a16="http://schemas.microsoft.com/office/drawing/2014/main" id="{6EF4BE8F-82F8-5599-57A2-4B5BAF6D3663}"/>
               </a:ext>
             </a:extLst>
           </p:cNvPr>
@@ -3517,7 +3517,7 @@
           <p:cNvPr id="8" name="TextBox 7">
             <a:extLst>
               <a:ext uri="{FF2B5EF4-FFF2-40B4-BE49-F238E27FC236}">
-                <a16:creationId xmlns:a16="http://schemas.microsoft.com/office/drawing/2014/main" id="{DD407E95-7018-DF44-188E-225E1C4E4026}"/>
+                <a16:creationId xmlns:a16="http://schemas.microsoft.com/office/drawing/2014/main" id="{7EB58921-31D0-EE08-0444-4940B376AE49}"/>
               </a:ext>
             </a:extLst>
           </p:cNvPr>
@@ -3557,7 +3557,7 @@
           <p:cNvPr id="9" name="TextBox 8">
             <a:extLst>
               <a:ext uri="{FF2B5EF4-FFF2-40B4-BE49-F238E27FC236}">
-                <a16:creationId xmlns:a16="http://schemas.microsoft.com/office/drawing/2014/main" id="{CD9797DA-78A3-BED0-2F83-AF344C6D6BF1}"/>
+                <a16:creationId xmlns:a16="http://schemas.microsoft.com/office/drawing/2014/main" id="{7FF14831-4792-B03D-F1A6-BDA22A5D368D}"/>
               </a:ext>
             </a:extLst>
           </p:cNvPr>
@@ -3566,7 +3566,7 @@
         </p:nvSpPr>
         <p:spPr>
           <a:xfrm>
-            <a:off x="355600" y="1066800"/>
+            <a:off x="355600" y="939800"/>
             <a:ext cx="4616831" cy="369332"/>
           </a:xfrm>
           <a:prstGeom prst="rect">
@@ -3618,7 +3618,7 @@
           <p:cNvPr id="10" name="TextBox 9">
             <a:extLst>
               <a:ext uri="{FF2B5EF4-FFF2-40B4-BE49-F238E27FC236}">
-                <a16:creationId xmlns:a16="http://schemas.microsoft.com/office/drawing/2014/main" id="{00C5F6DF-9707-6DEC-D1FB-B3BC36DF0ABA}"/>
+                <a16:creationId xmlns:a16="http://schemas.microsoft.com/office/drawing/2014/main" id="{03A5786C-D80E-3EC4-37BB-18D6D14C1C5D}"/>
               </a:ext>
             </a:extLst>
           </p:cNvPr>
@@ -3627,7 +3627,7 @@
         </p:nvSpPr>
         <p:spPr>
           <a:xfrm>
-            <a:off x="355600" y="2235200"/>
+            <a:off x="355600" y="2108200"/>
             <a:ext cx="4616831" cy="369332"/>
           </a:xfrm>
           <a:prstGeom prst="rect">
@@ -3642,13 +3642,13 @@
           <a:lstStyle/>
           <a:p>
             <a:r>
-              <a:rPr lang="en-US" sz="1300" b="1">
+              <a:rPr lang="en-US" sz="1200" b="1">
                 <a:solidFill>
                   <a:srgbClr val="FF5A36"/>
                 </a:solidFill>
                 <a:latin typeface="Arial" panose="020B0604020202020204" pitchFamily="34" charset="0"/>
               </a:rPr>
-              <a:t>Bachelor and master projects 2026–2027</a:t>
+              <a:t>BSc, BEng, MSc projects, and project course, 2026–2027</a:t>
             </a:r>
           </a:p>
         </p:txBody>
@@ -3658,7 +3658,7 @@
           <p:cNvPr id="11" name="TextBox 10">
             <a:extLst>
               <a:ext uri="{FF2B5EF4-FFF2-40B4-BE49-F238E27FC236}">
-                <a16:creationId xmlns:a16="http://schemas.microsoft.com/office/drawing/2014/main" id="{706BB18E-57F2-F7E3-52F1-29571E114250}"/>
+                <a16:creationId xmlns:a16="http://schemas.microsoft.com/office/drawing/2014/main" id="{C0856752-D305-BB01-27E2-38222892DF66}"/>
               </a:ext>
             </a:extLst>
           </p:cNvPr>
@@ -3667,7 +3667,7 @@
         </p:nvSpPr>
         <p:spPr>
           <a:xfrm>
-            <a:off x="355600" y="2590800"/>
+            <a:off x="355600" y="2438400"/>
             <a:ext cx="4362831" cy="369332"/>
           </a:xfrm>
           <a:prstGeom prst="rect">
@@ -3699,7 +3699,7 @@
                 </a:solidFill>
                 <a:latin typeface="Arial" panose="020B0604020202020204" pitchFamily="34" charset="0"/>
               </a:rPr>
-              <a:t>21 projects, many with partners in industry and research</a:t>
+              <a:t>Let's get inspired by the topics – many with industry partners</a:t>
             </a:r>
           </a:p>
           <a:p>
@@ -3721,7 +3721,7 @@
                 </a:solidFill>
                 <a:latin typeface="Arial" panose="020B0604020202020204" pitchFamily="34" charset="0"/>
               </a:rPr>
-              <a:t>Most projects can be done as group work – talk to the supervisors</a:t>
+              <a:t>Have your own idea? Discuss it with a supervisor in the field</a:t>
             </a:r>
           </a:p>
           <a:p>
@@ -3743,7 +3743,29 @@
                 </a:solidFill>
                 <a:latin typeface="Arial" panose="020B0604020202020204" pitchFamily="34" charset="0"/>
               </a:rPr>
-              <a:t>Not ready yet? Take a project course first – contact Karen Pantleon (kapa@dtu.dk)</a:t>
+              <a:t>Most projects can be done as group work – talk to the supervisors</a:t>
+            </a:r>
+          </a:p>
+          <a:p>
+            <a:pPr marL="152400" indent="-152400">
+              <a:spcAft>
+                <a:spcPts val="400"/>
+              </a:spcAft>
+              <a:buClr>
+                <a:srgbClr val="FF5A36"/>
+              </a:buClr>
+              <a:buSzPct val="70000"/>
+              <a:buFont typeface="+mj-lt"/>
+              <a:buChar char="■"/>
+            </a:pPr>
+            <a:r>
+              <a:rPr lang="en-US" sz="1000">
+                <a:solidFill>
+                  <a:srgbClr val="FFFFFF"/>
+                </a:solidFill>
+                <a:latin typeface="Arial" panose="020B0604020202020204" pitchFamily="34" charset="0"/>
+              </a:rPr>
+              <a:t>Feeling not ready yet? Take the Project course first (41667)</a:t>
             </a:r>
           </a:p>
         </p:txBody>
@@ -3753,7 +3775,7 @@
           <p:cNvPr id="12" name="TextBox 11">
             <a:extLst>
               <a:ext uri="{FF2B5EF4-FFF2-40B4-BE49-F238E27FC236}">
-                <a16:creationId xmlns:a16="http://schemas.microsoft.com/office/drawing/2014/main" id="{78AD3097-C72D-5F75-380F-BB1905B170FE}"/>
+                <a16:creationId xmlns:a16="http://schemas.microsoft.com/office/drawing/2014/main" id="{1713AB7E-B044-0C28-32F4-EA2DE9A6A109}"/>
               </a:ext>
             </a:extLst>
           </p:cNvPr>
@@ -3793,7 +3815,7 @@
           <p:cNvPr id="13" name="TextBox 12">
             <a:extLst>
               <a:ext uri="{FF2B5EF4-FFF2-40B4-BE49-F238E27FC236}">
-                <a16:creationId xmlns:a16="http://schemas.microsoft.com/office/drawing/2014/main" id="{7366DA8A-4E92-8614-1C7D-A51B942403DD}"/>
+                <a16:creationId xmlns:a16="http://schemas.microsoft.com/office/drawing/2014/main" id="{A978BC50-1734-19D9-85BF-6E658E69AD63}"/>
               </a:ext>
             </a:extLst>
           </p:cNvPr>
@@ -3833,7 +3855,7 @@
           <p:cNvPr id="14" name="Rectangle: Rounded Corners 13">
             <a:extLst>
               <a:ext uri="{FF2B5EF4-FFF2-40B4-BE49-F238E27FC236}">
-                <a16:creationId xmlns:a16="http://schemas.microsoft.com/office/drawing/2014/main" id="{BEDD80EB-61FC-B587-9A62-8727EB407803}"/>
+                <a16:creationId xmlns:a16="http://schemas.microsoft.com/office/drawing/2014/main" id="{BA136D1E-51F7-69BF-A909-CD25368FF8BD}"/>
               </a:ext>
             </a:extLst>
           </p:cNvPr>
@@ -3909,7 +3931,7 @@
           <p:cNvPr id="16" name="Picture 15">
             <a:extLst>
               <a:ext uri="{FF2B5EF4-FFF2-40B4-BE49-F238E27FC236}">
-                <a16:creationId xmlns:a16="http://schemas.microsoft.com/office/drawing/2014/main" id="{02324B50-D368-8FD1-127A-9224F9561815}"/>
+                <a16:creationId xmlns:a16="http://schemas.microsoft.com/office/drawing/2014/main" id="{A146CEE0-9676-195B-C9A3-B4FBA9DDA084}"/>
               </a:ext>
             </a:extLst>
           </p:cNvPr>
@@ -3945,7 +3967,7 @@
           <p:cNvPr id="17" name="TextBox 16">
             <a:extLst>
               <a:ext uri="{FF2B5EF4-FFF2-40B4-BE49-F238E27FC236}">
-                <a16:creationId xmlns:a16="http://schemas.microsoft.com/office/drawing/2014/main" id="{435723EC-34ED-4983-0226-A3815752666F}"/>
+                <a16:creationId xmlns:a16="http://schemas.microsoft.com/office/drawing/2014/main" id="{7C8C8CD0-24CA-4701-1A8F-5006D9F057C3}"/>
               </a:ext>
             </a:extLst>
           </p:cNvPr>
@@ -3998,7 +4020,7 @@
           <p:cNvPr id="18" name="Rectangle 17">
             <a:extLst>
               <a:ext uri="{FF2B5EF4-FFF2-40B4-BE49-F238E27FC236}">
-                <a16:creationId xmlns:a16="http://schemas.microsoft.com/office/drawing/2014/main" id="{8EFF63B4-6E8A-8D70-2FB1-2A1E367D9E0B}"/>
+                <a16:creationId xmlns:a16="http://schemas.microsoft.com/office/drawing/2014/main" id="{0978C05A-BE71-4C7A-20BA-2CCEDE3132B6}"/>
               </a:ext>
             </a:extLst>
           </p:cNvPr>
@@ -4053,7 +4075,7 @@
           <p:cNvPr id="19" name="Rectangle 18">
             <a:extLst>
               <a:ext uri="{FF2B5EF4-FFF2-40B4-BE49-F238E27FC236}">
-                <a16:creationId xmlns:a16="http://schemas.microsoft.com/office/drawing/2014/main" id="{DA71E08C-C19D-5EA3-3727-2BA8C9AAA3C3}"/>
+                <a16:creationId xmlns:a16="http://schemas.microsoft.com/office/drawing/2014/main" id="{FA2348BC-1F06-FCFE-6BC7-8D41281F523E}"/>
               </a:ext>
             </a:extLst>
           </p:cNvPr>
@@ -4108,7 +4130,7 @@
           <p:cNvPr id="20" name="TextBox 19">
             <a:extLst>
               <a:ext uri="{FF2B5EF4-FFF2-40B4-BE49-F238E27FC236}">
-                <a16:creationId xmlns:a16="http://schemas.microsoft.com/office/drawing/2014/main" id="{76678621-7918-C511-381C-8019F9EEBD66}"/>
+                <a16:creationId xmlns:a16="http://schemas.microsoft.com/office/drawing/2014/main" id="{A34C5712-6E76-25A8-6728-18EC33FF137A}"/>
               </a:ext>
             </a:extLst>
           </p:cNvPr>
@@ -4147,7 +4169,7 @@
     </p:spTree>
     <p:extLst>
       <p:ext uri="{BB962C8B-B14F-4D97-AF65-F5344CB8AC3E}">
-        <p14:creationId xmlns:p14="http://schemas.microsoft.com/office/powerpoint/2010/main" val="1119650514"/>
+        <p14:creationId xmlns:p14="http://schemas.microsoft.com/office/powerpoint/2010/main" val="26604295"/>
       </p:ext>
     </p:extLst>
   </p:cSld>

</xml_diff>